<commit_message>
Switch project theme to LINE local AI expense tracker
- relay_server: parse_expense, append/read expenses, expense_summary, /demo/expenses
- Code.gs: route expense messages (e.g. 咖啡 45 元) to local relay
- demo UI: expense chat flow with today/monthly totals
- docs: report, summary, slides, scripts, screenshots updated to expense theme
- tests: add 17-test suite covering expense parsing and demo APIs
</commit_message>
<xml_diff>
--- a/docs/期中展示.pptx
+++ b/docs/期中展示.pptx
@@ -508,7 +508,7 @@
           <a:lstStyle/>
           <a:p>
             <a:r>
-              <a:t>0:00–0:10｜開場。這是一個放在 LINE 裡的助手，只做兩件事：查資料、記事情。今天用展示頁跑給大家看，因為它和 LINE 版共用同一個流程，但不需要把 token 放進畫面。</a:t>
+              <a:t>0:00–0:10｜開場。這是一個放在 LINE 裡的 AI 記帳小幫手；今天用展示頁跑給大家看，因為它和 LINE 版共用同一個流程，但不需要把 token 放進畫面。</a:t>
             </a:r>
           </a:p>
         </p:txBody>
@@ -578,7 +578,7 @@
           <a:lstStyle/>
           <a:p>
             <a:r>
-              <a:t>0:10–0:20｜問題有三個：查資料要跳 App、待辦散在聊天、雲端 AI 有費用與隱私顾虑。這個專案給誰用？主要是常用 LINE 的學生與小型團隊。</a:t>
+              <a:t>0:10–0:20｜問題有三個：記帳要開 App、查資料要切 App、雲端 AI 有費用與隱私顾虑。這個專案給誰用？主要是常用 LINE 的學生與小型團隊。</a:t>
             </a:r>
           </a:p>
         </p:txBody>
@@ -648,7 +648,7 @@
           <a:lstStyle/>
           <a:p>
             <a:r>
-              <a:t>0:20–0:55｜先講兩種模式，再點『查 玉山有多高』。等待時指右側流程：Apps Script 收訊息、Flask 搜尋、Ollama 生成。答案出來後指來源與 5.9 秒。接著點『買牛奶』，讓待辦出現在右側。</a:t>
+              <a:t>0:20–0:55｜先講兩種模式，再點『咖啡 45 元』。等待時指右側流程：Apps Script 收訊息、Flask 本地解析、累計、回覆。接著點『Uber 60』，讓累計加總。</a:t>
             </a:r>
           </a:p>
         </p:txBody>
@@ -858,7 +858,7 @@
           <a:lstStyle/>
           <a:p>
             <a:r>
-              <a:t>1:25–1:35｜11 個測試全過，暖機後 5.9 秒，掃描 0 金鑰。限制要主動講：電腦要開、網址會變、搜尋很淺、Webhook 還沒驗簽章。</a:t>
+              <a:t>1:25–1:35｜17 個測試全過，暖機後記帳約 0.3 秒，掃描 0 金鑰。限制要主動講：電腦要開、網址會變、分類是 heuristic、Webhook 還沒驗簽章。</a:t>
             </a:r>
           </a:p>
         </p:txBody>
@@ -928,7 +928,7 @@
           <a:lstStyle/>
           <a:p>
             <a:r>
-              <a:t>1:35–1:30｜收尾。下一步是固定網域、補 Webhook 簽章、待辦進化、檢索進化。最後說：90 秒，讓它跑一次，謝謝。</a:t>
+              <a:t>1:35–1:30｜收尾。下一步是固定網域、補 Webhook 簽章、記帳進化、檢索進化。最後說：90 秒，讓它跑一次，謝謝。</a:t>
             </a:r>
           </a:p>
         </p:txBody>
@@ -4117,7 +4117,7 @@
                 </a:solidFill>
                 <a:latin typeface="Microsoft JhengHei"/>
               </a:rPr>
-              <a:t>會查資料的</a:t>
+              <a:t>會記帳的</a:t>
             </a:r>
           </a:p>
         </p:txBody>
@@ -4162,7 +4162,7 @@
                 </a:solidFill>
                 <a:latin typeface="Microsoft JhengHei"/>
               </a:rPr>
-              <a:t>待辦小幫手</a:t>
+              <a:t>AI 記帳小幫手</a:t>
             </a:r>
           </a:p>
         </p:txBody>
@@ -4229,7 +4229,7 @@
                 </a:solidFill>
                 <a:latin typeface="Microsoft JhengHei"/>
               </a:rPr>
-              <a:t>「查 …」得到有來源的答案；其他訊息自動變成待辦。</a:t>
+              <a:t>「咖啡 45 元」自動記帳、分類、累計；「查 …」得到有來源的答案。</a:t>
             </a:r>
           </a:p>
         </p:txBody>
@@ -4319,7 +4319,7 @@
                 </a:solidFill>
                 <a:latin typeface="Microsoft JhengHei"/>
               </a:rPr>
-              <a:t>本機推論</a:t>
+              <a:t>記帳自動分類</a:t>
             </a:r>
           </a:p>
         </p:txBody>
@@ -4499,7 +4499,7 @@
                 </a:solidFill>
                 <a:latin typeface="Microsoft JhengHei"/>
               </a:rPr>
-              <a:t>附上來源</a:t>
+              <a:t>今日＋本月累計</a:t>
             </a:r>
           </a:p>
         </p:txBody>
@@ -4544,7 +4544,7 @@
                 </a:solidFill>
                 <a:latin typeface="Microsoft JhengHei"/>
               </a:rPr>
-              <a:t>90 秒 Demo：查 玉山有多高  →  買牛奶</a:t>
+              <a:t>90 秒 Demo：咖啡 45 元  →  Uber 60</a:t>
             </a:r>
           </a:p>
         </p:txBody>
@@ -4790,7 +4790,7 @@
         <p:spPr>
           <a:xfrm>
             <a:off x="658368" y="868680"/>
-            <a:ext cx="10515600" cy="1188720"/>
+            <a:ext cx="10515600" cy="914400"/>
           </a:xfrm>
           <a:prstGeom prst="rect">
             <a:avLst/>
@@ -4821,29 +4821,7 @@
                 </a:solidFill>
                 <a:latin typeface="Microsoft JhengHei"/>
               </a:rPr>
-              <a:t>問題不是「沒有 AI」，</a:t>
-            </a:r>
-          </a:p>
-          <a:p>
-            <a:pPr algn="l">
-              <a:lnSpc>
-                <a:spcPct val="112000"/>
-              </a:lnSpc>
-              <a:spcBef>
-                <a:spcPts val="0"/>
-              </a:spcBef>
-              <a:spcAft>
-                <a:spcPts val="0"/>
-              </a:spcAft>
-            </a:pPr>
-            <a:r>
-              <a:rPr sz="3000" b="1">
-                <a:solidFill>
-                  <a:srgbClr val="122019"/>
-                </a:solidFill>
-                <a:latin typeface="Microsoft JhengHei"/>
-              </a:rPr>
-              <a:t>是每天多做了幾次切換。</a:t>
+              <a:t>記帳，本來就該很簡單。</a:t>
             </a:r>
           </a:p>
         </p:txBody>
@@ -4980,7 +4958,7 @@
                 </a:solidFill>
                 <a:latin typeface="Microsoft JhengHei"/>
               </a:rPr>
-              <a:t>查資料要跳 App</a:t>
+              <a:t>記帳要開 App</a:t>
             </a:r>
           </a:p>
         </p:txBody>
@@ -5025,7 +5003,7 @@
                 </a:solidFill>
                 <a:latin typeface="Microsoft JhengHei"/>
               </a:rPr>
-              <a:t>在 LINE 看到問題，切到瀏覽器搜尋，看完再切回來。</a:t>
+              <a:t>手動打類別、換工具、整理匯總。</a:t>
             </a:r>
           </a:p>
           <a:p>
@@ -5047,7 +5025,7 @@
                 </a:solidFill>
                 <a:latin typeface="Microsoft JhengHei"/>
               </a:rPr>
-              <a:t>注意力被切成三段。</a:t>
+              <a:t>不想為每筆花費開一個 App。</a:t>
             </a:r>
           </a:p>
         </p:txBody>
@@ -5184,7 +5162,7 @@
                 </a:solidFill>
                 <a:latin typeface="Microsoft JhengHei"/>
               </a:rPr>
-              <a:t>待辦散在聊天裡</a:t>
+              <a:t>查資料要切 App</a:t>
             </a:r>
           </a:p>
         </p:txBody>
@@ -5229,7 +5207,7 @@
                 </a:solidFill>
                 <a:latin typeface="Microsoft JhengHei"/>
               </a:rPr>
-              <a:t>「買牛奶」被後面的訊息洗掉；</a:t>
+              <a:t>在 LINE 裡問，切到瀏覽器搜尋，看完再切回來。</a:t>
             </a:r>
           </a:p>
           <a:p>
@@ -5251,7 +5229,7 @@
                 </a:solidFill>
                 <a:latin typeface="Microsoft JhengHei"/>
               </a:rPr>
-              <a:t>記事軟體又常常懶得開。</a:t>
+              <a:t>注意力被切成三段。</a:t>
             </a:r>
           </a:p>
         </p:txBody>
@@ -5545,7 +5523,7 @@
                 </a:solidFill>
                 <a:latin typeface="Microsoft JhengHei"/>
               </a:rPr>
-              <a:t>主要使用者：常用 LINE 的學生與小型團隊　·　設計目標：不離開聊天室、答案可查證、沒有逐字費用</a:t>
+              <a:t>主要使用者：常用 LINE 的學生與小型團隊　·　設計目標：不離開聊天室、記帳免 API、累計即時</a:t>
             </a:r>
           </a:p>
         </p:txBody>
@@ -5751,7 +5729,7 @@
                 </a:solidFill>
                 <a:latin typeface="Microsoft JhengHei"/>
               </a:rPr>
-              <a:t>一個入口，兩種工作流。</a:t>
+              <a:t>一個入口，兩種模式。</a:t>
             </a:r>
           </a:p>
         </p:txBody>
@@ -5936,28 +5914,6 @@
               <a:t>查 玉山有多高   →   3,950 公尺＋Wikipedia 來源</a:t>
             </a:r>
           </a:p>
-          <a:p>
-            <a:pPr algn="l">
-              <a:lnSpc>
-                <a:spcPct val="140000"/>
-              </a:lnSpc>
-              <a:spcBef>
-                <a:spcPts val="0"/>
-              </a:spcBef>
-              <a:spcAft>
-                <a:spcPts val="0"/>
-              </a:spcAft>
-            </a:pPr>
-            <a:r>
-              <a:rPr sz="1050" b="0">
-                <a:solidFill>
-                  <a:srgbClr val="66756C"/>
-                </a:solidFill>
-                <a:latin typeface="Microsoft JhengHei"/>
-              </a:rPr>
-              <a:t>查 今天台灣有什麼新聞   →   新聞摘要＋媒體來源</a:t>
-            </a:r>
-          </a:p>
         </p:txBody>
       </p:sp>
       <p:sp>
@@ -6047,7 +6003,7 @@
                 </a:solidFill>
                 <a:latin typeface="Microsoft JhengHei"/>
               </a:rPr>
-              <a:t>記事情</a:t>
+              <a:t>咖啡 45 元</a:t>
             </a:r>
           </a:p>
         </p:txBody>
@@ -6092,7 +6048,7 @@
                 </a:solidFill>
                 <a:latin typeface="Microsoft JhengHei"/>
               </a:rPr>
-              <a:t>不是「查」開頭的訊息，直接寫進 Google Sheet 待辦。</a:t>
+              <a:t>本地解析 merchant＋amount，分類後累計今日／本月。</a:t>
             </a:r>
           </a:p>
         </p:txBody>
@@ -6137,7 +6093,7 @@
                 </a:solidFill>
                 <a:latin typeface="Microsoft JhengHei"/>
               </a:rPr>
-              <a:t>買牛奶   →   已記錄到待辦：買牛奶</a:t>
+              <a:t>咖啡 45 元 → 已記帳（飲食），今日累計…</a:t>
             </a:r>
           </a:p>
         </p:txBody>
@@ -7711,7 +7667,7 @@
                 </a:solidFill>
                 <a:latin typeface="Microsoft JhengHei"/>
               </a:rPr>
-              <a:t>測試：11/11，沒有僥倖。</a:t>
+              <a:t>測試：17/17，沒有僥倖。</a:t>
             </a:r>
           </a:p>
         </p:txBody>
@@ -7803,7 +7759,7 @@
                 </a:solidFill>
                 <a:latin typeface="Microsoft JhengHei"/>
               </a:rPr>
-              <a:t>11 / 11</a:t>
+              <a:t>17 / 17</a:t>
             </a:r>
           </a:p>
         </p:txBody>
@@ -7985,7 +7941,7 @@
                 </a:solidFill>
                 <a:latin typeface="Microsoft JhengHei"/>
               </a:rPr>
-              <a:t>5.9 秒</a:t>
+              <a:t>0.3 秒</a:t>
             </a:r>
           </a:p>
         </p:txBody>
@@ -8030,7 +7986,7 @@
                 </a:solidFill>
                 <a:latin typeface="Microsoft JhengHei"/>
               </a:rPr>
-              <a:t>暖機後查詢</a:t>
+              <a:t>暖機後記帳</a:t>
             </a:r>
           </a:p>
         </p:txBody>
@@ -8075,7 +8031,7 @@
                 </a:solidFill>
                 <a:latin typeface="Microsoft JhengHei"/>
               </a:rPr>
-              <a:t>展示頁實測，含搜尋與生成</a:t>
+              <a:t>本地累計即時更新</a:t>
             </a:r>
           </a:p>
         </p:txBody>
@@ -9566,7 +9522,7 @@
                 </a:solidFill>
                 <a:latin typeface="Microsoft JhengHei"/>
               </a:rPr>
-              <a:t>待辦進化</a:t>
+              <a:t>記帳進化</a:t>
             </a:r>
           </a:p>
         </p:txBody>
@@ -9611,7 +9567,7 @@
                 </a:solidFill>
                 <a:latin typeface="Microsoft JhengHei"/>
               </a:rPr>
-              <a:t>列表／完成／刪除</a:t>
+              <a:t>AI 分類／預算警示</a:t>
             </a:r>
           </a:p>
           <a:p>
@@ -9633,7 +9589,7 @@
                 </a:solidFill>
                 <a:latin typeface="Microsoft JhengHei"/>
               </a:rPr>
-              <a:t>或串 Google Tasks</a:t>
+              <a:t>或使用者自訂類別</a:t>
             </a:r>
           </a:p>
         </p:txBody>

</xml_diff>